<commit_message>
Deck slide 13: 41 / 41; journal: full regression, slow-table RTL demo, user's GPU run
Co-Authored-By: Claude Sonnet 5.5 <noreply@anthropic.com>
Claude-Session: https://claude.ai/code/session_013SV3SfseaABNzbLHJy34eL
</commit_message>
<xml_diff>
--- a/docs/L_pitch_final.pptx
+++ b/docs/L_pitch_final.pptx
@@ -129,18 +129,18 @@
   <p:extLst>
     <p:ext uri="{521415D9-36F7-43E2-AB2F-B90AF26B5E84}">
       <p14:sectionLst xmlns:p14="http://schemas.microsoft.com/office/powerpoint/2010/main">
-        <p14:section name="Open" id="{e0f99968-55f0-8be1-8da3-8d3705dde2a1}">
+        <p14:section name="Open" id="{105d047f-d3b5-7e70-437d-96fba08b4524}">
           <p14:sldIdLst>
             <p14:sldId id="256"/>
           </p14:sldIdLst>
         </p14:section>
-        <p14:section name="Why" id="{31177b26-ba3f-dcfe-7f5b-66dd50776afa}">
+        <p14:section name="Why" id="{2bce28d9-e430-e81d-2bb8-565139bdb100}">
           <p14:sldIdLst>
             <p14:sldId id="257"/>
             <p14:sldId id="258"/>
           </p14:sldIdLst>
         </p14:section>
-        <p14:section name="Results" id="{32c76abf-70c8-7c1b-d027-6d509609f093}">
+        <p14:section name="Results" id="{0f09ae9b-6f3e-4832-a2ab-f01d6b2e6e02}">
           <p14:sldIdLst>
             <p14:sldId id="259"/>
             <p14:sldId id="260"/>
@@ -151,7 +151,7 @@
             <p14:sldId id="265"/>
           </p14:sldIdLst>
         </p14:section>
-        <p14:section name="Build" id="{88e09d1d-1965-a5e5-86f7-3cfcd3e268f0}">
+        <p14:section name="Build" id="{eea46fdc-0cb5-d640-8cbe-4fc0edfca124}">
           <p14:sldIdLst>
             <p14:sldId id="266"/>
             <p14:sldId id="267"/>
@@ -159,7 +159,7 @@
             <p14:sldId id="269"/>
           </p14:sldIdLst>
         </p14:section>
-        <p14:section name="Honest" id="{3c51b4b9-0cbc-7696-1d46-9dc58c6d10b5}">
+        <p14:section name="Honest" id="{a1b6de98-e989-0611-43f6-29f39b8c3018}">
           <p14:sldIdLst>
             <p14:sldId id="270"/>
             <p14:sldId id="271"/>
@@ -167,7 +167,7 @@
             <p14:sldId id="273"/>
           </p14:sldIdLst>
         </p14:section>
-        <p14:section name="Next" id="{5e67a275-0230-0a87-1687-8924e02b1a81}">
+        <p14:section name="Next" id="{96fd8617-9019-4baf-28a1-81bb75dabb44}">
           <p14:sldIdLst>
             <p14:sldId id="274"/>
             <p14:sldId id="275"/>
@@ -7636,7 +7636,7 @@
                 <a:ea typeface="Cambria" pitchFamily="34" charset="-122"/>
                 <a:cs typeface="Cambria" pitchFamily="34" charset="-120"/>
               </a:rPr>
-              <a:t>38 / 38</a:t>
+              <a:t>41 / 41</a:t>
             </a:r>
             <a:endParaRPr lang="en-US" sz="5400" dirty="0"/>
           </a:p>
@@ -7675,7 +7675,7 @@
                 <a:ea typeface="Calibri" pitchFamily="34" charset="-122"/>
                 <a:cs typeface="Calibri" pitchFamily="34" charset="-120"/>
               </a:rPr>
-              <a:t>RTL checks in one full run, 0 mismatches against the integer model: core, tail memory, IMPRINT, slow table, encoders, cochlea, sound chain, two-sense chip, cue weighting, second look, threshold and novelty units, clustering, board top, host schedule. Newer checks pass on their own: stage and night sequencer, raw senses to a whole stage.</a:t>
+              <a:t>RTL checks in one full run, 0 mismatches against the integer model: core, tail memory, IMPRINT, slow table, encoders, cochlea, sound chain, two-sense chip, cue weighting, second look, threshold and novelty units, clustering, stage and night sequencer, raw senses to a whole stage, board top, host schedule.</a:t>
             </a:r>
             <a:endParaRPr lang="en-US" sz="1200" dirty="0"/>
           </a:p>

</xml_diff>

<commit_message>
Final pitch speaker script; deck slide 15 routing now 0 violations (router count); GPU slide cycle count corrected
Co-Authored-By: Claude Sonnet 5.5 <noreply@anthropic.com>
Claude-Session: https://claude.ai/code/session_013SV3SfseaABNzbLHJy34eL
</commit_message>
<xml_diff>
--- a/docs/L_pitch_final.pptx
+++ b/docs/L_pitch_final.pptx
@@ -131,18 +131,18 @@
   <p:extLst>
     <p:ext uri="{521415D9-36F7-43E2-AB2F-B90AF26B5E84}">
       <p14:sectionLst xmlns:p14="http://schemas.microsoft.com/office/powerpoint/2010/main">
-        <p14:section name="Open" id="{7303cbbe-3d93-7e5f-b2e5-d0de84e128be}">
+        <p14:section name="Open" id="{8e88749d-86b3-66c6-43e5-e23f739c3dd4}">
           <p14:sldIdLst>
             <p14:sldId id="256"/>
           </p14:sldIdLst>
         </p14:section>
-        <p14:section name="Why" id="{c69cb0d0-8ee2-de01-34df-994fcb049d69}">
+        <p14:section name="Why" id="{160ab0e5-948e-ed11-9c48-3fc7b629912c}">
           <p14:sldIdLst>
             <p14:sldId id="257"/>
             <p14:sldId id="258"/>
           </p14:sldIdLst>
         </p14:section>
-        <p14:section name="Results" id="{d5d171ad-7d4d-5e07-06f5-64f5fb015ef2}">
+        <p14:section name="Results" id="{53e93599-9ad9-60d9-7218-4f2d0c6f0d64}">
           <p14:sldIdLst>
             <p14:sldId id="259"/>
             <p14:sldId id="260"/>
@@ -154,7 +154,7 @@
             <p14:sldId id="266"/>
           </p14:sldIdLst>
         </p14:section>
-        <p14:section name="Build" id="{94957d34-bdd1-a24c-9286-fd606c6ace02}">
+        <p14:section name="Build" id="{57f41c4a-a58b-b1b9-90ea-f587ff563315}">
           <p14:sldIdLst>
             <p14:sldId id="267"/>
             <p14:sldId id="268"/>
@@ -163,7 +163,7 @@
             <p14:sldId id="271"/>
           </p14:sldIdLst>
         </p14:section>
-        <p14:section name="Honest" id="{e58bb73f-e951-c2ac-d88c-ba7be760b7de}">
+        <p14:section name="Honest" id="{3724e71c-d21b-f19d-a90e-7a7a60e7b8b2}">
           <p14:sldIdLst>
             <p14:sldId id="272"/>
             <p14:sldId id="273"/>
@@ -171,7 +171,7 @@
             <p14:sldId id="275"/>
           </p14:sldIdLst>
         </p14:section>
-        <p14:section name="Next" id="{c237821a-dd89-7dcf-cfce-bf58d2ddb1a4}">
+        <p14:section name="Next" id="{52e656de-04ed-79c2-60da-2afb75dc543c}">
           <p14:sldIdLst>
             <p14:sldId id="276"/>
             <p14:sldId id="277"/>
@@ -3578,7 +3578,7 @@
           <a:p>
             <a:r>
               <a:rPr lang="en-US" dirty="0"/>
-              <a:t>We ran the same decision on a real laptop GPU, an RTX 3050, and on our chip design in simulation. The GPU numbers are measured. At batch one it takes about 1.8 milliseconds and 69 millijoules per decision; at batch 1024 it reaches 22 thousand decisions a second. The chip design needs 2,900 clock cycles for the FPGA build, which is about 56 microseconds at 27 megahertz, and about 12 microseconds for the pipelined option. Those times and the 9.4 nanojoule energy are estimates from simulation, not board measurements. A trained network is still more accurate when everything is learned at once; our case is learning in stages without forgetting.</a:t>
+              <a:t>We ran the same decision on a real laptop GPU, an RTX 3050, and on our chip design in simulation. The GPU numbers are measured. At batch one it takes about 1.8 milliseconds and 69 millijoules per decision; at batch 1024 it reaches 22 thousand decisions a second. The chip design needs about 1,500 clock cycles per decision in the FPGA build, which is about 56 microseconds at 27 megahertz, and about 320 cycles, 12 microseconds, for the pipelined option. Those times and the 9.4 nanojoule energy are estimates from simulation, not board measurements. A trained network is still more accurate when everything is learned at once; our case is learning in stages without forgetting.</a:t>
             </a:r>
             <a:endParaRPr lang="en-US" dirty="0"/>
           </a:p>
@@ -3754,7 +3754,7 @@
           <a:p>
             <a:r>
               <a:rPr lang="en-US" dirty="0"/>
-              <a:t>The design is not just a simulator result. Every check passes bit for bit between the integer model and the RTL, covering the learning core, the sense layers, the whole sound chain, the two-sense chip, the new units that moved host steps onto the chip, and the board top. We also took it through an open-source SKY130 layout flow; routing ended at one remaining violation. This is verification in simulation, not a chip.</a:t>
+              <a:t>The design is not just a simulator result. Every check passes bit for bit between the integer model and the RTL, covering the learning core, the sense layers, the whole sound chain, the two-sense chip, the new units that moved host steps onto the chip, and the board top. We also took it through an open-source SKY130 layout flow; routing ends at zero violations by the router's own count. This is verification in simulation, not a chip.</a:t>
             </a:r>
             <a:endParaRPr lang="en-US" dirty="0"/>
           </a:p>
@@ -10015,7 +10015,7 @@
                 <a:ea typeface="Cambria" pitchFamily="34" charset="-122"/>
                 <a:cs typeface="Cambria" pitchFamily="34" charset="-120"/>
               </a:rPr>
-              <a:t>1</a:t>
+              <a:t>0</a:t>
             </a:r>
             <a:endParaRPr lang="en-US" sz="5400" dirty="0"/>
           </a:p>
@@ -10054,7 +10054,7 @@
                 <a:ea typeface="Calibri" pitchFamily="34" charset="-122"/>
                 <a:cs typeface="Calibri" pitchFamily="34" charset="-120"/>
               </a:rPr>
-              <a:t>violation left in detailed routing of the SKY130 layout (from 174,309 on the first pass), a power-versus-signal short at a memory macro edge.</a:t>
+              <a:t>violations left in detailed routing of the SKY130 layout (router count; 145,000 on the first pass), re-run from scratch. A layout in the open flow, not a signed-off or fabricated chip.</a:t>
             </a:r>
             <a:endParaRPr lang="en-US" sz="1300" dirty="0"/>
           </a:p>

</xml_diff>

<commit_message>
Deck: remove speaker notes from the pptx (script stays in pitch_script_final.md)
Co-Authored-By: Claude Sonnet 5.5 <noreply@anthropic.com>
Claude-Session: https://claude.ai/code/session_013SV3SfseaABNzbLHJy34eL
</commit_message>
<xml_diff>
--- a/docs/L_pitch_final.pptx
+++ b/docs/L_pitch_final.pptx
@@ -137,19 +137,19 @@
   <p:extLst>
     <p:ext uri="{521415D9-36F7-43E2-AB2F-B90AF26B5E84}">
       <p14:sectionLst xmlns:p14="http://schemas.microsoft.com/office/powerpoint/2010/main">
-        <p14:section name="Open" id="{30457739-d5cf-13cb-8e28-f57b8dfc5af5}">
+        <p14:section name="Open" id="{018e7294-8959-19e6-4870-a4a6247a35c8}">
           <p14:sldIdLst>
             <p14:sldId id="256"/>
           </p14:sldIdLst>
         </p14:section>
-        <p14:section name="Why" id="{f6b56da5-9c0c-a56b-3aa9-34b7d0a7c404}">
+        <p14:section name="Why" id="{2101627f-81fd-ef1d-f9e9-f4106ec0aebc}">
           <p14:sldIdLst>
             <p14:sldId id="257"/>
             <p14:sldId id="258"/>
             <p14:sldId id="259"/>
           </p14:sldIdLst>
         </p14:section>
-        <p14:section name="Results" id="{6a0c224a-c742-448a-cb41-30c5fd5075d5}">
+        <p14:section name="Results" id="{35245809-108a-730b-3d2d-9b4c50b7fd2e}">
           <p14:sldIdLst>
             <p14:sldId id="260"/>
             <p14:sldId id="261"/>
@@ -162,7 +162,7 @@
             <p14:sldId id="268"/>
           </p14:sldIdLst>
         </p14:section>
-        <p14:section name="Build" id="{527c952c-e2c2-d5ee-8454-a71cc3c2e883}">
+        <p14:section name="Build" id="{5c731dda-0616-2e4a-bf74-773cd9786abf}">
           <p14:sldIdLst>
             <p14:sldId id="269"/>
             <p14:sldId id="270"/>
@@ -173,7 +173,7 @@
             <p14:sldId id="275"/>
           </p14:sldIdLst>
         </p14:section>
-        <p14:section name="Honest" id="{34131d52-696b-31a3-37d2-a7def2120cb0}">
+        <p14:section name="Honest" id="{e1d24628-768b-952b-1bb3-d0ccf94c12d6}">
           <p14:sldIdLst>
             <p14:sldId id="276"/>
             <p14:sldId id="277"/>
@@ -183,7 +183,7 @@
             <p14:sldId id="281"/>
           </p14:sldIdLst>
         </p14:section>
-        <p14:section name="Next" id="{b8b467a7-4c80-3026-888f-8c009a04f815}">
+        <p14:section name="Next" id="{eeed35f6-5a93-4c17-f06c-adf3a5d9d287}">
           <p14:sldIdLst>
             <p14:sldId id="282"/>
             <p14:sldId id="283"/>
@@ -3238,7 +3238,7 @@
           <a:p>
             <a:r>
               <a:rPr lang="en-US" dirty="0"/>
-              <a:t>Hello judges. We are L Lawliet from CKCET and the project is called L. L is a small chip design that keeps learning after it ships, without forgetting what it knew, with no multiplier, no matrices and no backpropagation. One promise before the numbers: every number on these slides is labelled simulated, estimated or measured, and nothing has run on a real board yet.</a:t>
+              <a:t/>
             </a:r>
             <a:endParaRPr lang="en-US" dirty="0"/>
           </a:p>
@@ -3326,7 +3326,7 @@
           <a:p>
             <a:r>
               <a:rPr lang="en-US" dirty="0"/>
-              <a:t>A retina and a cochlea feed one table. When a quarter of the picture is damaged, weighting each sense by how confident it is lifts digits from 97.5 to 98.4. A heard word can name pictures with no picture labels, groups can form with no labels, and the chip can notice a new class by itself. Be honest: the pictures and sounds come from different datasets that share only the digit.</a:t>
+              <a:t/>
             </a:r>
             <a:endParaRPr lang="en-US" dirty="0"/>
           </a:p>
@@ -3414,7 +3414,7 @@
           <a:p>
             <a:r>
               <a:rPr lang="en-US" dirty="0"/>
-              <a:t>A brand-new class seen once was almost invisible. IMPRINT writes its mean code into the table at once and a short sleep blends it in: digits go from 54 to 70, clothing from 50 to 64. Spoken words from one to five recordings stay weak and I say so on the limits slide.</a:t>
+              <a:t/>
             </a:r>
             <a:endParaRPr lang="en-US" dirty="0"/>
           </a:p>
@@ -3502,7 +3502,7 @@
           <a:p>
             <a:r>
               <a:rPr lang="en-US" dirty="0"/>
-              <a:t>One chip works alone; sharing is an option. Because the memory is counts, two chips that learned different classes can be merged by adding their counters, or one chip hands its memory to another that keeps learning. Merge gives 93, 81 and 64 percent; hand-over gives 96, 83 and 72. A normal network cannot merge two separately trained copies like this. A GPU cluster joins many GPUs for size and speed, which is a different thing.</a:t>
+              <a:t/>
             </a:r>
             <a:endParaRPr lang="en-US" dirty="0"/>
           </a:p>
@@ -3590,7 +3590,7 @@
           <a:p>
             <a:r>
               <a:rPr lang="en-US" dirty="0"/>
-              <a:t>This is the whole design. Sensors feed a retina and a cochlea, which turn pictures and sound into on and off bits. The sensory cortex picks the best matching detectors and makes a sparse code of 4,608 bits. The fast table keeps a small counter for every class and bit; adding up the counters for the bits that are on gives the answer, with no multiplier. The dream memory keeps per-class counts so the chip can dream old classes at night and not forget them. A sequencer runs day and night. Everything here is design and simulation; nothing has run on a board yet.</a:t>
+              <a:t/>
             </a:r>
             <a:endParaRPr lang="en-US" dirty="0"/>
           </a:p>
@@ -3678,7 +3678,7 @@
           <a:p>
             <a:r>
               <a:rPr lang="en-US" dirty="0"/>
-              <a:t>Cost. The image memory is 84 kilobytes and fits a 25-dollar Tang Nano 20K with no hardware multipliers. Counting only the operations a decision needs it uses about 74 times less energy than an 8-bit network, an estimate. The layout estimate is higher, about a fifth of a microjoule. The second look costs about 2.8 times the table memory, and sound needs 422 kilobytes.</a:t>
+              <a:t/>
             </a:r>
             <a:endParaRPr lang="en-US" dirty="0"/>
           </a:p>
@@ -3766,7 +3766,7 @@
           <a:p>
             <a:r>
               <a:rPr lang="en-US" dirty="0"/>
-              <a:t>We ran the same decision on a real laptop GPU, an RTX 3050, and on our chip design in simulation. The GPU numbers are measured. At batch one it takes about 1.8 milliseconds and 69 millijoules per decision; at batch 1024 it reaches 22 thousand decisions a second. The chip design needs about 1,500 clock cycles per decision in the FPGA build, which is about 56 microseconds at 27 megahertz, and about 320 cycles, 12 microseconds, for the pipelined option. Those times and the 9.4 nanojoule energy are estimates from simulation, not board measurements. A trained network is still more accurate when everything is learned at once; our case is learning in stages without forgetting.</a:t>
+              <a:t/>
             </a:r>
             <a:endParaRPr lang="en-US" dirty="0"/>
           </a:p>
@@ -3854,7 +3854,7 @@
           <a:p>
             <a:r>
               <a:rPr lang="en-US" dirty="0"/>
-              <a:t>Where does the GPU use more power, and where does L use less? Four processes. One decision on its own: my laptop GPU used 69 millijoules, measured; the chip design is estimated at about 0.2 microjoule from the layout and 9 nanojoules by counting operations. In a crowd of a thousand the GPU improves to about 2 millijoules, but a device decides one input at a time. Learning from 59 thousand digit images: the CNN's whole training run used 1,148 joules, measured; the chip learns each example once, in place, estimated at about 45 to 62 microjoules per example, so about 3 joules in all. And learning a new class later: the GPU has to retrain in a data centre, and in stages it forgets, 19.6 percent; the chip learns it in place with dreams. Read these as orders of magnitude. The chip numbers are estimates for the core only, with no board or memory interface; the GPU numbers are the whole GPU. The GPU still wins at training big models and at batched throughput on big jobs. The board run will measure L.</a:t>
+              <a:t/>
             </a:r>
             <a:endParaRPr lang="en-US" dirty="0"/>
           </a:p>
@@ -3942,7 +3942,7 @@
           <a:p>
             <a:r>
               <a:rPr lang="en-US" dirty="0"/>
-              <a:t>Why should you agree with us? Because for one specific job we are better, and I can show it. The job is learning on the device, with a small memory, one input at a time. For that job: in staged learning on 59 thousand images the chip ends at 95.5 percent and a real CNN, which I ran on my own GPU, ends at 19.6. The chip needs 84 kilobytes and no multiplier, and by operation count uses about 74 times less energy per decision, which is an estimate I will measure on the board. The design is checked bit for bit. And when everything is learned at once the CNN is still ahead, 99.1 to 97.9, and I say that. We do not replace the GPU: keep it for training and for big models.</a:t>
+              <a:t/>
             </a:r>
             <a:endParaRPr lang="en-US" dirty="0"/>
           </a:p>
@@ -4030,7 +4030,7 @@
           <a:p>
             <a:r>
               <a:rPr lang="en-US" dirty="0"/>
-              <a:t>Why this belongs with embedded systems. It is a dedicated function inside a device under tight limits: 84 kilobytes of memory for images, no multiplier, a small low-cost FPGA. It has real device interfaces: a camera-style picture input and microphone samples encoded on the chip, and a UART byte protocol so any microcontroller or PC can teach it, ask it, and read or write its memory. We simulated the board's top-level design end to end: digits recognised from UART bytes. On the device it learns new classes in the field, sleeps when idle, and its memory can be moved between devices. The honest limit: real power, latency and clock speed are not measured yet; they need the board run.</a:t>
+              <a:t/>
             </a:r>
             <a:endParaRPr lang="en-US" dirty="0"/>
           </a:p>
@@ -4118,7 +4118,7 @@
           <a:p>
             <a:r>
               <a:rPr lang="en-US" dirty="0"/>
-              <a:t>The design is not just a simulator result. Every check passes bit for bit between the integer model and the RTL, covering the learning core, the sense layers, the whole sound chain, the two-sense chip, the new units that moved host steps onto the chip, and the board top. We also took it through an open-source SKY130 layout flow; routing ends at zero violations by the router's own count. This is verification in simulation, not a chip.</a:t>
+              <a:t/>
             </a:r>
             <a:endParaRPr lang="en-US" dirty="0"/>
           </a:p>
@@ -4206,7 +4206,7 @@
           <a:p>
             <a:r>
               <a:rPr lang="en-US" dirty="0"/>
-              <a:t>A normal neural network learns once. Teach it in stages and it keeps only the last stage: about 20 percent on digits and clothing, and 5 percent on twenty classes. Those are measured numbers from a small CNN we trained on the same images, one seed. The usual fix is to retrain from scratch, which costs energy and means hardware cannot be updated in the field. A chip that learns in the field avoids that.</a:t>
+              <a:t/>
             </a:r>
             <a:endParaRPr lang="en-US" dirty="0"/>
           </a:p>
@@ -4294,7 +4294,7 @@
           <a:p>
             <a:r>
               <a:rPr lang="en-US" dirty="0"/>
-              <a:t>This is the design, so you can check it. Pictures and sound go through detectors that learn without labels and make a sparse code. The core is a fast five-bit table, ten-bit dream counters for sleep and a slow consolidating table, using counts, compares and shifts, with no multiplier. The decision is an XNOR and popcount. On top are the units we added: the second look, the tail memory, the confidence weighting of two senses, and the threshold, novelty and grouping units. Each has a Verilog file, a testbench and a script that compares it bit for bit with the integer model. One command reruns every check. The repository and logs are available to reviewers on request. Everything is simulated.</a:t>
+              <a:t/>
             </a:r>
             <a:endParaRPr lang="en-US" dirty="0"/>
           </a:p>
@@ -4382,7 +4382,7 @@
           <a:p>
             <a:r>
               <a:rPr lang="en-US" dirty="0"/>
-              <a:t>Be clear about scope. L solves a small part of the AI problem: devices that must keep learning in the field without retraining on a server and without being thrown away. That is simulated, and the energy figure is an estimate. L does not solve what is driving GPU and memory prices today, which is large language models and image generators in data centres. It also cannot run existing models: it is a dedicated chip for its own model. And nothing is measured on hardware yet.</a:t>
+              <a:t/>
             </a:r>
             <a:endParaRPr lang="en-US" dirty="0"/>
           </a:p>
@@ -4470,7 +4470,7 @@
           <a:p>
             <a:r>
               <a:rPr lang="en-US" dirty="0"/>
-              <a:t>Why must we alter the model or make our own, and what is wrong with the current architecture? A transformer is not wrong; it is built for a data centre. The trouble for a device is its structure: every word does dense maths on every weight, attention keeps a memory that grows with the text, the weights are frozen, and learning needs backpropagation, which needs gradients and a lot of memory. If we only built a faster chip for that same model, we would have a GPU or a TPU, and those already exist with far more money behind them. So the model has to change too: a constant-size state, sparse activity so only a few rows are touched, low-bit or counting weights, and local learning by counting. We either alter an existing model to those rules or design a new one, and build the chip for exactly that. Model and chip designed together is the L bet. The small version works, as classifiers. The language-model version is untested, and it comes with tests that can prove it wrong.</a:t>
+              <a:t/>
             </a:r>
             <a:endParaRPr lang="en-US" dirty="0"/>
           </a:p>
@@ -4558,7 +4558,7 @@
           <a:p>
             <a:r>
               <a:rPr lang="en-US" dirty="0"/>
-              <a:t>Can real AI models run on L? Three routes, and I want to be exact about the status. One: alter an existing model. Ternary models, with weights of minus one, zero and plus one, replace multiplications with additions; published work runs language models of billions of parameters this way. That still has a matrix of additions, so it breaks our no-matrix rule, but it shows the multiplier is not needed. Two: design our own model. A counting language model hashes the recent words into a sparse code and a table of counters predicts the next word one bit at a time. The counting classifier works in simulation; the language model is the next experiment. Three: grow the memory. Big tables go in outside DRAM, and because only a few rows are touched per word the bandwidth stays small. First we test, in simulation, whether quality grows with table size. So we claim the route and the tests that can prove it wrong, not a billion-parameter result.</a:t>
+              <a:t/>
             </a:r>
             <a:endParaRPr lang="en-US" dirty="0"/>
           </a:p>
@@ -4646,7 +4646,7 @@
           <a:p>
             <a:r>
               <a:rPr lang="en-US" dirty="0"/>
-              <a:t>This is the hypothesis, said as a hypothesis. A brain-style model with a constant-size state, sparse event-driven activity and low-bit weights, on a chip built for it, should need much less memory traffic and energy per token than a transformer on a GPU at the same quality. That could reduce the demand for scarce high-bandwidth memory and the heat and water of serving. The model has to be proven first, because the chip can only exploit those properties. It is falsified if the quality edge disappears at larger sizes or when matrix-free, if a fused GPU version gets within about three times of the simulated chip, or if a transformer chip with the same memory matches the energy per token. The thresholds are my proposals, not data.</a:t>
+              <a:t/>
             </a:r>
             <a:endParaRPr lang="en-US" dirty="0"/>
           </a:p>
@@ -4734,7 +4734,7 @@
           <a:p>
             <a:r>
               <a:rPr lang="en-US" dirty="0"/>
-              <a:t>This is the slide I want you to remember. Nothing has run on hardware. Staged clothing is about 82 percent, five points under its one-pass number, and I tried many fixes. A trained CNN is still ahead on clothing by about two points. The tests are small and the noise is simulated; the two-sense data is paired by class, not real audio-visual recordings. The second look costs about 2.8 times the memory, and a few steps still run on the host.</a:t>
+              <a:t/>
             </a:r>
             <a:endParaRPr lang="en-US" dirty="0"/>
           </a:p>
@@ -4822,7 +4822,7 @@
           <a:p>
             <a:r>
               <a:rPr lang="en-US" dirty="0"/>
-              <a:t>We are not the first continual-learning chip. Hyperdimensional-computing accelerators and event-driven spiking chips such as Loihi 2, TrueNorth and SpiNNaker exist. What we add is the combination: dreams from small counters so no examples are stored, a night that ends by itself, consolidation that scales with the data, and a design with no multiplier or matrix that is bit-exact from raw senses to the decision.</a:t>
+              <a:t/>
             </a:r>
             <a:endParaRPr lang="en-US" dirty="0"/>
           </a:p>
@@ -4910,7 +4910,7 @@
           <a:p>
             <a:r>
               <a:rPr lang="en-US" dirty="0"/>
-              <a:t>What comes next. The model and RTL are done and verified in simulation. The next milestone is the real Tang Nano board, which gives the first measured numbers. Then harder tests: a larger vocabulary, real recorded noise and a harder image set. Later, a matrix-free chip for the L language model, and external memory for sound and the second look. No fabrication is planned yet.</a:t>
+              <a:t/>
             </a:r>
             <a:endParaRPr lang="en-US" dirty="0"/>
           </a:p>
@@ -4998,7 +4998,7 @@
           <a:p>
             <a:r>
               <a:rPr lang="en-US" dirty="0"/>
-              <a:t>We plan to approach the bigger problem on two tracks. Track one is the L chip, which is done in simulation and next goes to a real board. Track two is the L AI model for language, which has small-scale evidence only, so it goes through gates: first measure the model, then compare against a fused GPU implementation and stop if the GPU is already close, then check that a matrix-free version keeps its quality. Only then a simulator and an FPGA. Later we study memory: whether the constant-size state and event-driven reads can move work from scarce high-bandwidth memory to cheaper DRAM or on-chip memory. That is a question to study, not a claim.</a:t>
+              <a:t/>
             </a:r>
             <a:endParaRPr lang="en-US" dirty="0"/>
           </a:p>
@@ -5086,7 +5086,7 @@
           <a:p>
             <a:r>
               <a:rPr lang="en-US" dirty="0"/>
-              <a:t>On fabrication. The open 130 nanometre flow is good for a prototype but not comparable to a GPU. Today's data-centre GPUs use a five-nanometre-class process and dies up to about 800 square millimetres. Reaching that node costs tens of millions of dollars and needs foundry access we do not have, so we will not claim it. The plan is to write the design independent of the node, compare energy against GPUs at a GPU-class node using published scaling, which is an uncertain estimate, prove the design on an FPGA, and tape out at an accessible mature node, around 28 to 65 nanometres through a university or shuttle programme, when funded. Silicon CMOS is the only practical material for dense logic: mature, high yield, full tools. Its limits are cost at advanced nodes, heat, SRAM that no longer shrinks as fast, and supply concentrated in a few fabs. Other materials are not ready for dense logic. All cost figures are estimates from memory of public reports; verify before quoting.</a:t>
+              <a:t/>
             </a:r>
             <a:endParaRPr lang="en-US" dirty="0"/>
           </a:p>
@@ -5174,7 +5174,7 @@
           <a:p>
             <a:r>
               <a:rPr lang="en-US" dirty="0"/>
-              <a:t>The question a judge will ask: what is wrong with the transformer and the GPU? Nothing, for what they were built for. They are excellent at training and at big batches in a data centre. But three things hurt on a device. First, the model is frozen after training; teaching it something new means retraining in a data centre, and a network trained on new things forgets old ones. Second, generating each word reads every weight and keeps a memory that grows with the text, so at one input at a time the chip waits for memory. Third, I measured it: on my laptop GPU one decision costs 69 millijoules when it is alone and 1.95 when batched with a thousand others, 35 times worse. A phone or a sensor decides one at a time. Heat, cooling water and electronic waste follow from the power; they are our motivation, and we have not measured them.</a:t>
+              <a:t/>
             </a:r>
             <a:endParaRPr lang="en-US" dirty="0"/>
           </a:p>
@@ -5262,7 +5262,7 @@
           <a:p>
             <a:r>
               <a:rPr lang="en-US" dirty="0"/>
-              <a:t>What we need to go further, in steps, each with a pass criterion. Step one is the FPGA board run, about four thousand rupees including tax, and it gives the first measured numbers: bit-exact agreement with the simulation, accuracy and power. Step two is a micro-chip on a shared shuttle, around a hundred to three hundred dollars per tile, to show the verified on-chip units in real silicon. Step three is a full chip at a mature node through a university or programme partner, tens of thousands of dollars. Step four, a GPU-class node, costs tens of millions and is not requested now. Besides money we welcome a partner for shuttle access, a mentor, and compute credits for the language-model gates. All prices are estimates; verify before committing.</a:t>
+              <a:t/>
             </a:r>
             <a:endParaRPr lang="en-US" dirty="0"/>
           </a:p>
@@ -5350,7 +5350,7 @@
           <a:p>
             <a:r>
               <a:rPr lang="en-US" dirty="0"/>
-              <a:t>To close: L is a chip design that keeps learning after it ships. It keeps what it knew, shares what it learned, and needs no multiplier. It is weaker than a trained network in a few places, and I have told you where. Thank you, I am happy to take questions.</a:t>
+              <a:t/>
             </a:r>
             <a:endParaRPr lang="en-US" dirty="0"/>
           </a:p>
@@ -5438,7 +5438,7 @@
           <a:p>
             <a:r>
               <a:rPr lang="en-US" dirty="0"/>
-              <a:t>Our rule is to follow the brain, not the GPU. Senses that learn without labels. Learning by counting, one example at a time, with no backpropagation, no multiplier and no matrices. Sleep: the chip dreams old classes from small counters instead of storing examples, and a slow table consolidates the fast one. Looking again when unsure, and trusting the more confident sense. And sharing: memory is counts, so chips can merge.</a:t>
+              <a:t/>
             </a:r>
             <a:endParaRPr lang="en-US" dirty="0"/>
           </a:p>
@@ -5526,7 +5526,7 @@
           <a:p>
             <a:r>
               <a:rPr lang="en-US" dirty="0"/>
-              <a:t>This is the core result. Learning in stages of two classes with no stored examples, the chip keeps 95.6 percent on digits and 81 on clothing with sixty thousand training images, and 87.4 percent on twenty classes. The CNN that learned in the same stages keeps about 20 and 5 percent. The chip numbers are simulated with an exact integer model, two to five seeds; the CNN numbers are measured, one seed.</a:t>
+              <a:t/>
             </a:r>
             <a:endParaRPr lang="en-US" dirty="0"/>
           </a:p>
@@ -5614,7 +5614,7 @@
           <a:p>
             <a:r>
               <a:rPr lang="en-US" dirty="0"/>
-              <a:t>With everything available at once, the chip with its second look is within half a point of a trained CNN on digits, two points behind on clothing, level on twenty classes, and level on thirty-five spoken words even though the chip learned the words in stages. The second look costs about 2.8 times the table memory. Say it plainly: a CNN is still ahead on clothing.</a:t>
+              <a:t/>
             </a:r>
             <a:endParaRPr lang="en-US" dirty="0"/>
           </a:p>
@@ -5702,7 +5702,7 @@
           <a:p>
             <a:r>
               <a:rPr lang="en-US" dirty="0"/>
-              <a:t>How did we test it? Three ways. One: we ran standard tasks on an integer model of the chip, which is exactly the arithmetic the chip does: handwritten digits, clothing images, spoken digits and words. We tried all at once, in stages with two classes at a time, with noise, with two senses, a new class from one example, and merging two chips, with three to five random seeds and a held-out speaker. Two: we compared against a CNN and a small network trained on the same data, and the CNN ran on my own RTX 3050 laptop GPU so the accuracy, time and energy are real measurements. Three: we checked the design. The Verilog matches the Python model bit for bit in 41 of 41 checks; the real-cell netlist matches; a formal equivalence check passed; and the cycles per decision come from the RTL simulation. What we did not test: a language model or any large model on the chip, a board run, real-world noise or large vocabularies. The models we ran are classifiers; the CNN is only the ruler.</a:t>
+              <a:t/>
             </a:r>
             <a:endParaRPr lang="en-US" dirty="0"/>
           </a:p>
@@ -5790,7 +5790,7 @@
           <a:p>
             <a:r>
               <a:rPr lang="en-US" dirty="0"/>
-              <a:t>We tested whether the chip holds up with more data, and found a failure: at sixty thousand images the staged result fell. The cause was consolidation timing; one fixed rule that scales the follow interval with the stage size removes the collapse, on both datasets, without a per-dataset setting. We also report that one-pass accuracy barely improves with more data.</a:t>
+              <a:t/>
             </a:r>
             <a:endParaRPr lang="en-US" dirty="0"/>
           </a:p>
@@ -5878,7 +5878,7 @@
           <a:p>
             <a:r>
               <a:rPr lang="en-US" dirty="0"/>
-              <a:t>The sound path goes from raw samples through a cochlea and noise floor to the same counting table. With one noisy copy of each training clip and a second look, thirty-five words in stages reach 72.4 percent clean and 47 percent at 5 decibels, against 68 and 27 for the first design. The noise is simulated white noise, not real recordings.</a:t>
+              <a:t/>
             </a:r>
             <a:endParaRPr lang="en-US" dirty="0"/>
           </a:p>

</xml_diff>

<commit_message>
Deck and script: first counting language model result; printable script refreshed
Co-Authored-By: Claude Sonnet 5.5 <noreply@anthropic.com>
Claude-Session: https://claude.ai/code/session_013SV3SfseaABNzbLHJy34eL
</commit_message>
<xml_diff>
--- a/docs/L_pitch_final.pptx
+++ b/docs/L_pitch_final.pptx
@@ -137,19 +137,19 @@
   <p:extLst>
     <p:ext uri="{521415D9-36F7-43E2-AB2F-B90AF26B5E84}">
       <p14:sectionLst xmlns:p14="http://schemas.microsoft.com/office/powerpoint/2010/main">
-        <p14:section name="Open" id="{018e7294-8959-19e6-4870-a4a6247a35c8}">
+        <p14:section name="Open" id="{8ca6166b-66ff-ef75-db22-ee3813481cf3}">
           <p14:sldIdLst>
             <p14:sldId id="256"/>
           </p14:sldIdLst>
         </p14:section>
-        <p14:section name="Why" id="{2101627f-81fd-ef1d-f9e9-f4106ec0aebc}">
+        <p14:section name="Why" id="{36253ae0-e715-bcea-f784-ace0c1d642ef}">
           <p14:sldIdLst>
             <p14:sldId id="257"/>
             <p14:sldId id="258"/>
             <p14:sldId id="259"/>
           </p14:sldIdLst>
         </p14:section>
-        <p14:section name="Results" id="{35245809-108a-730b-3d2d-9b4c50b7fd2e}">
+        <p14:section name="Results" id="{900eca8a-498d-8d6a-4177-cbec56b025b4}">
           <p14:sldIdLst>
             <p14:sldId id="260"/>
             <p14:sldId id="261"/>
@@ -162,7 +162,7 @@
             <p14:sldId id="268"/>
           </p14:sldIdLst>
         </p14:section>
-        <p14:section name="Build" id="{5c731dda-0616-2e4a-bf74-773cd9786abf}">
+        <p14:section name="Build" id="{e9ff383a-eb5d-5c38-9abb-c6b5adb225cd}">
           <p14:sldIdLst>
             <p14:sldId id="269"/>
             <p14:sldId id="270"/>
@@ -173,7 +173,7 @@
             <p14:sldId id="275"/>
           </p14:sldIdLst>
         </p14:section>
-        <p14:section name="Honest" id="{e1d24628-768b-952b-1bb3-d0ccf94c12d6}">
+        <p14:section name="Honest" id="{1d74fe94-e1e3-d3d2-82bf-ea97526b0cd3}">
           <p14:sldIdLst>
             <p14:sldId id="276"/>
             <p14:sldId id="277"/>
@@ -183,7 +183,7 @@
             <p14:sldId id="281"/>
           </p14:sldIdLst>
         </p14:section>
-        <p14:section name="Next" id="{eeed35f6-5a93-4c17-f06c-adf3a5d9d287}">
+        <p14:section name="Next" id="{6ef4a4db-48b4-0fb2-cc1b-dbbe1bc83ca8}">
           <p14:sldIdLst>
             <p14:sldId id="282"/>
             <p14:sldId id="283"/>
@@ -15793,7 +15793,7 @@
                 <a:ea typeface="Calibri" pitchFamily="34" charset="-122"/>
                 <a:cs typeface="Calibri" pitchFamily="34" charset="-120"/>
               </a:rPr>
-              <a:t>Honest status: the small version works (L Cortex, classifiers). The language-model version is untested, with tests that can prove it wrong.</a:t>
+              <a:t>Honest status: the small version works (L Cortex, classifiers). A first test of a counting language model is in (next slide); a neural comparison and the chip mapping are not done.</a:t>
             </a:r>
             <a:endParaRPr lang="en-US" sz="1100" dirty="0"/>
           </a:p>
@@ -16153,7 +16153,7 @@
                 <a:ea typeface="Calibri" pitchFamily="34" charset="-122"/>
                 <a:cs typeface="Calibri" pitchFamily="34" charset="-120"/>
               </a:rPr>
-              <a:t>A counting language model: hash the recent words into a sparse code, a table of counters predicts the next word one bit at a time. No multiplier, no matrix, and it learns on the device.</a:t>
+              <a:t>A counting language model: hash the recent characters or words into a sparse code, a table of counters predicts the next one, a bit at a time. No multiplier, no matrix, and it learns on the device.</a:t>
             </a:r>
             <a:endParaRPr lang="en-US" sz="1300" dirty="0"/>
           </a:p>
@@ -16192,7 +16192,7 @@
                 <a:ea typeface="Calibri" pitchFamily="34" charset="-122"/>
                 <a:cs typeface="Calibri" pitchFamily="34" charset="-120"/>
               </a:rPr>
-              <a:t>Counting classifier SIMULATED; language model is the next test</a:t>
+              <a:t>First test SIMULATED: 4.8 to 1.8 bits per character as memory grows 8 KB to 8 MB</a:t>
             </a:r>
             <a:endParaRPr lang="en-US" sz="1000" dirty="0"/>
           </a:p>
@@ -16297,7 +16297,7 @@
                 <a:ea typeface="Calibri" pitchFamily="34" charset="-122"/>
                 <a:cs typeface="Calibri" pitchFamily="34" charset="-120"/>
               </a:rPr>
-              <a:t>Big tables live in outside DRAM. Sparse lookups touch only a few rows per word, so bandwidth stays small. First test: quality against table size in simulation, then a board with DRAM.</a:t>
+              <a:t>Big tables live in outside DRAM. Sparse lookups touch only a few rows per word, so bandwidth stays small. Simulated: quality grows with table size. Next: a board with DRAM.</a:t>
             </a:r>
             <a:endParaRPr lang="en-US" sz="1300" dirty="0"/>
           </a:p>
@@ -16402,7 +16402,7 @@
                 <a:ea typeface="Calibri" pitchFamily="34" charset="-122"/>
                 <a:cs typeface="Calibri" pitchFamily="34" charset="-120"/>
               </a:rPr>
-              <a:t>Status: we claim the route and the tests that can prove it wrong, not a billion-parameter result. The chip today is the small version of this idea.</a:t>
+              <a:t>First result: a counting language model learned English text online in one pass (SIMULATED algorithm test, not on the chip, no neural comparison yet). We claim the route, not a billion-parameter result.</a:t>
             </a:r>
             <a:endParaRPr lang="en-US" sz="1100" dirty="0"/>
           </a:p>

</xml_diff>

<commit_message>
Level 3: measured activity from RTL simulation of real MNIST images; end-to-end 14 uJ per image; deck and benchmark corrected
Co-Authored-By: Claude Sonnet 5.5 <noreply@anthropic.com>
Claude-Session: https://claude.ai/code/session_013SV3SfseaABNzbLHJy34eL
</commit_message>
<xml_diff>
--- a/docs/L_pitch_final.pptx
+++ b/docs/L_pitch_final.pptx
@@ -137,19 +137,19 @@
   <p:extLst>
     <p:ext uri="{521415D9-36F7-43E2-AB2F-B90AF26B5E84}">
       <p14:sectionLst xmlns:p14="http://schemas.microsoft.com/office/powerpoint/2010/main">
-        <p14:section name="Open" id="{8ca6166b-66ff-ef75-db22-ee3813481cf3}">
+        <p14:section name="Open" id="{a658f979-2cd4-dd1f-9c0e-24d50b844eb8}">
           <p14:sldIdLst>
             <p14:sldId id="256"/>
           </p14:sldIdLst>
         </p14:section>
-        <p14:section name="Why" id="{36253ae0-e715-bcea-f784-ace0c1d642ef}">
+        <p14:section name="Why" id="{fdeb9ace-c52e-e5af-6082-a13693f2fb13}">
           <p14:sldIdLst>
             <p14:sldId id="257"/>
             <p14:sldId id="258"/>
             <p14:sldId id="259"/>
           </p14:sldIdLst>
         </p14:section>
-        <p14:section name="Results" id="{900eca8a-498d-8d6a-4177-cbec56b025b4}">
+        <p14:section name="Results" id="{969a78f7-4b07-41b3-c8ae-8dc8b10e35cc}">
           <p14:sldIdLst>
             <p14:sldId id="260"/>
             <p14:sldId id="261"/>
@@ -162,7 +162,7 @@
             <p14:sldId id="268"/>
           </p14:sldIdLst>
         </p14:section>
-        <p14:section name="Build" id="{e9ff383a-eb5d-5c38-9abb-c6b5adb225cd}">
+        <p14:section name="Build" id="{d7f36791-f770-3a0b-11df-1f1bf9b0d859}">
           <p14:sldIdLst>
             <p14:sldId id="269"/>
             <p14:sldId id="270"/>
@@ -173,7 +173,7 @@
             <p14:sldId id="275"/>
           </p14:sldIdLst>
         </p14:section>
-        <p14:section name="Honest" id="{1d74fe94-e1e3-d3d2-82bf-ea97526b0cd3}">
+        <p14:section name="Honest" id="{acc55769-b89b-b681-eec3-6b98c05ef842}">
           <p14:sldIdLst>
             <p14:sldId id="276"/>
             <p14:sldId id="277"/>
@@ -183,7 +183,7 @@
             <p14:sldId id="281"/>
           </p14:sldIdLst>
         </p14:section>
-        <p14:section name="Next" id="{6ef4a4db-48b4-0fb2-cc1b-dbbe1bc83ca8}">
+        <p14:section name="Next" id="{44ac909e-992d-36ae-7815-daf137cb4e50}">
           <p14:sldIdLst>
             <p14:sldId id="282"/>
             <p14:sldId id="283"/>
@@ -8380,7 +8380,7 @@
                 <a:ea typeface="Cambria" pitchFamily="34" charset="-122"/>
                 <a:cs typeface="Cambria" pitchFamily="34" charset="-120"/>
               </a:rPr>
-              <a:t>Deciding one digit: chip design vs a real GPU</a:t>
+              <a:t>Picture to answer: chip vs a real GPU</a:t>
             </a:r>
             <a:endParaRPr lang="en-US" sz="3000" dirty="0"/>
           </a:p>
@@ -8433,7 +8433,7 @@
                           <a:ea typeface="Calibri" pitchFamily="34" charset="-122"/>
                           <a:cs typeface="Calibri" pitchFamily="34" charset="-120"/>
                         </a:rPr>
-                        <a:t>One digit image</a:t>
+                        <a:t>One image, start to finish</a:t>
                       </a:r>
                       <a:endParaRPr lang="en-US" sz="1200" dirty="0">
                         <a:latin typeface="Calibri" charset="0"/>
@@ -8569,7 +8569,7 @@
                           <a:ea typeface="Calibri" pitchFamily="34" charset="-122"/>
                           <a:cs typeface="Calibri" pitchFamily="34" charset="-120"/>
                         </a:rPr>
-                        <a:t>Decisions/s</a:t>
+                        <a:t>Images/s</a:t>
                       </a:r>
                       <a:endParaRPr lang="en-US" sz="1200" dirty="0">
                         <a:latin typeface="Calibri" charset="0"/>
@@ -8775,7 +8775,7 @@
                           <a:ea typeface="Calibri" pitchFamily="34" charset="-122"/>
                           <a:cs typeface="Calibri" pitchFamily="34" charset="-120"/>
                         </a:rPr>
-                        <a:t>L chip, FPGA build, 27 MHz</a:t>
+                        <a:t>L chip, encoder + decision, FPGA clock 27 MHz</a:t>
                       </a:r>
                       <a:endParaRPr lang="en-US" sz="1200" dirty="0">
                         <a:latin typeface="Calibri" charset="0"/>
@@ -8843,7 +8843,7 @@
                           <a:ea typeface="Calibri" pitchFamily="34" charset="-122"/>
                           <a:cs typeface="Calibri" pitchFamily="34" charset="-120"/>
                         </a:rPr>
-                        <a:t>55.7 us</a:t>
+                        <a:t>0.83 ms</a:t>
                       </a:r>
                       <a:endParaRPr lang="en-US" sz="1200" dirty="0">
                         <a:latin typeface="Calibri" charset="0"/>
@@ -8911,7 +8911,7 @@
                           <a:ea typeface="Calibri" pitchFamily="34" charset="-122"/>
                           <a:cs typeface="Calibri" pitchFamily="34" charset="-120"/>
                         </a:rPr>
-                        <a:t>17,952</a:t>
+                        <a:t>1,200</a:t>
                       </a:r>
                       <a:endParaRPr lang="en-US" sz="1200" dirty="0">
                         <a:latin typeface="Calibri" charset="0"/>
@@ -8979,7 +8979,7 @@
                           <a:ea typeface="Calibri" pitchFamily="34" charset="-122"/>
                           <a:cs typeface="Calibri" pitchFamily="34" charset="-120"/>
                         </a:rPr>
-                        <a:t>9.4 nJ</a:t>
+                        <a:t>about 14 uJ</a:t>
                       </a:r>
                       <a:endParaRPr lang="en-US" sz="1200" dirty="0">
                         <a:latin typeface="Calibri" charset="0"/>
@@ -9047,7 +9047,7 @@
                           <a:ea typeface="Calibri" pitchFamily="34" charset="-122"/>
                           <a:cs typeface="Calibri" pitchFamily="34" charset="-120"/>
                         </a:rPr>
-                        <a:t>cycles SIMULATED, time and energy ESTIMATED</a:t>
+                        <a:t>cycles SIMULATED; time, energy ESTIMATED (layout, measured activity)</a:t>
                       </a:r>
                       <a:endParaRPr lang="en-US" sz="1200" dirty="0">
                         <a:latin typeface="Calibri" charset="0"/>
@@ -9117,7 +9117,7 @@
                           <a:ea typeface="Calibri" pitchFamily="34" charset="-122"/>
                           <a:cs typeface="Calibri" pitchFamily="34" charset="-120"/>
                         </a:rPr>
-                        <a:t>L chip, pipelined (ASIC option)</a:t>
+                        <a:t>L chip, decision from the code only (pipelined)</a:t>
                       </a:r>
                       <a:endParaRPr lang="en-US" sz="1200" dirty="0">
                         <a:latin typeface="Calibri" charset="0"/>
@@ -9321,7 +9321,7 @@
                           <a:ea typeface="Calibri" pitchFamily="34" charset="-122"/>
                           <a:cs typeface="Calibri" pitchFamily="34" charset="-120"/>
                         </a:rPr>
-                        <a:t>9.4 nJ</a:t>
+                        <a:t>0.25 uJ</a:t>
                       </a:r>
                       <a:endParaRPr lang="en-US" sz="1200" dirty="0">
                         <a:latin typeface="Calibri" charset="0"/>
@@ -9389,7 +9389,7 @@
                           <a:ea typeface="Calibri" pitchFamily="34" charset="-122"/>
                           <a:cs typeface="Calibri" pitchFamily="34" charset="-120"/>
                         </a:rPr>
-                        <a:t>cycles SIMULATED, time and energy ESTIMATED</a:t>
+                        <a:t>the encoder, 21,378 cycles, is NOT in this row; ESTIMATED</a:t>
                       </a:r>
                       <a:endParaRPr lang="en-US" sz="1200" dirty="0">
                         <a:latin typeface="Calibri" charset="0"/>
@@ -9527,7 +9527,7 @@
                           <a:ea typeface="Calibri" pitchFamily="34" charset="-122"/>
                           <a:cs typeface="Calibri" pitchFamily="34" charset="-120"/>
                         </a:rPr>
-                        <a:t>1,809 us</a:t>
+                        <a:t>0.42 to 1.8 ms</a:t>
                       </a:r>
                       <a:endParaRPr lang="en-US" sz="1200" dirty="0">
                         <a:latin typeface="Calibri" charset="0"/>
@@ -9595,7 +9595,7 @@
                           <a:ea typeface="Calibri" pitchFamily="34" charset="-122"/>
                           <a:cs typeface="Calibri" pitchFamily="34" charset="-120"/>
                         </a:rPr>
-                        <a:t>553</a:t>
+                        <a:t>553 to 2,373</a:t>
                       </a:r>
                       <a:endParaRPr lang="en-US" sz="1200" dirty="0">
                         <a:latin typeface="Calibri" charset="0"/>
@@ -9663,7 +9663,7 @@
                           <a:ea typeface="Calibri" pitchFamily="34" charset="-122"/>
                           <a:cs typeface="Calibri" pitchFamily="34" charset="-120"/>
                         </a:rPr>
-                        <a:t>69.3 mJ</a:t>
+                        <a:t>12.6 to 69 mJ</a:t>
                       </a:r>
                       <a:endParaRPr lang="en-US" sz="1200" dirty="0">
                         <a:latin typeface="Calibri" charset="0"/>
@@ -9731,7 +9731,7 @@
                           <a:ea typeface="Calibri" pitchFamily="34" charset="-122"/>
                           <a:cs typeface="Calibri" pitchFamily="34" charset="-120"/>
                         </a:rPr>
-                        <a:t>MEASURED</a:t>
+                        <a:t>MEASURED, two runs</a:t>
                       </a:r>
                       <a:endParaRPr lang="en-US" sz="1200" dirty="0">
                         <a:latin typeface="Calibri" charset="0"/>
@@ -9937,7 +9937,7 @@
                           <a:ea typeface="Calibri" pitchFamily="34" charset="-122"/>
                           <a:cs typeface="Calibri" pitchFamily="34" charset="-120"/>
                         </a:rPr>
-                        <a:t>22,226</a:t>
+                        <a:t>22,000 to 98,000</a:t>
                       </a:r>
                       <a:endParaRPr lang="en-US" sz="1200" dirty="0">
                         <a:latin typeface="Calibri" charset="0"/>
@@ -10005,7 +10005,7 @@
                           <a:ea typeface="Calibri" pitchFamily="34" charset="-122"/>
                           <a:cs typeface="Calibri" pitchFamily="34" charset="-120"/>
                         </a:rPr>
-                        <a:t>1.95 mJ</a:t>
+                        <a:t>0.29 to 1.95 mJ</a:t>
                       </a:r>
                       <a:endParaRPr lang="en-US" sz="1200" dirty="0">
                         <a:latin typeface="Calibri" charset="0"/>
@@ -10073,7 +10073,7 @@
                           <a:ea typeface="Calibri" pitchFamily="34" charset="-122"/>
                           <a:cs typeface="Calibri" pitchFamily="34" charset="-120"/>
                         </a:rPr>
-                        <a:t>MEASURED</a:t>
+                        <a:t>MEASURED, two runs</a:t>
                       </a:r>
                       <a:endParaRPr lang="en-US" sz="1200" dirty="0">
                         <a:latin typeface="Calibri" charset="0"/>
@@ -10137,7 +10137,7 @@
         </p:nvSpPr>
         <p:spPr>
           <a:xfrm>
-            <a:off x="457200" y="3429000"/>
+            <a:off x="457200" y="3657600"/>
             <a:ext cx="8229600" cy="960120"/>
           </a:xfrm>
           <a:prstGeom prst="roundRect">
@@ -10164,7 +10164,7 @@
         </p:nvSpPr>
         <p:spPr>
           <a:xfrm>
-            <a:off x="594360" y="3493008"/>
+            <a:off x="594360" y="3721608"/>
             <a:ext cx="7955280" cy="868680"/>
           </a:xfrm>
           <a:prstGeom prst="rect">
@@ -10189,7 +10189,7 @@
                 <a:ea typeface="Calibri" pitchFamily="34" charset="-122"/>
                 <a:cs typeface="Calibri" pitchFamily="34" charset="-120"/>
               </a:rPr>
-              <a:t>Read it honestly: chip times are cycle counts from the RTL simulation divided by 27 MHz, not a board run, and the chip energy is an operation count, not a power reading. The GPU rows were measured on a laptop GPU. One chip serves one stream; the GPU wins on throughput when it can batch. A trained CNN is still ahead on accuracy when all classes are learned at once (99.1% vs 97.9% at 59k images); the chip's case is learning classes in stages without forgetting (CNN fell to 19.6%).</a:t>
+              <a:t>Read it honestly: picture to answer, the chip spends 21,378 of its 22,500 cycles in the encoder, so at 27 MHz it is NOT faster than this GPU at batch 1; its advantage is energy (about 14 uJ against 12.6 to 69 mJ) and learning on the device. Chip rows are a layout estimate, no board run. The GPU range is two runs: its power state changes the result.</a:t>
             </a:r>
             <a:endParaRPr lang="en-US" sz="1100" dirty="0"/>
           </a:p>
@@ -10626,7 +10626,7 @@
                           <a:ea typeface="Calibri" pitchFamily="34" charset="-122"/>
                           <a:cs typeface="Calibri" pitchFamily="34" charset="-120"/>
                         </a:rPr>
-                        <a:t>One decision, alone (batch 1)</a:t>
+                        <a:t>One image to answer, alone (batch 1)</a:t>
                       </a:r>
                       <a:endParaRPr lang="en-US" sz="1100" dirty="0">
                         <a:latin typeface="Calibri" charset="0"/>
@@ -10694,7 +10694,7 @@
                           <a:ea typeface="Calibri" pitchFamily="34" charset="-122"/>
                           <a:cs typeface="Calibri" pitchFamily="34" charset="-120"/>
                         </a:rPr>
-                        <a:t>69.3 mJ  MEASURED</a:t>
+                        <a:t>12.6 to 69 mJ  MEASURED (two runs)</a:t>
                       </a:r>
                       <a:endParaRPr lang="en-US" sz="1100" dirty="0">
                         <a:latin typeface="Calibri" charset="0"/>
@@ -10762,7 +10762,7 @@
                           <a:ea typeface="Calibri" pitchFamily="34" charset="-122"/>
                           <a:cs typeface="Calibri" pitchFamily="34" charset="-120"/>
                         </a:rPr>
-                        <a:t>0.18 to 0.26 uJ layout estimate; 9.4 nJ by operation count  ESTIMATED</a:t>
+                        <a:t>about 14 uJ end to end (encoder 13 uJ); 9.3 nJ by operation count  ESTIMATED</a:t>
                       </a:r>
                       <a:endParaRPr lang="en-US" sz="1100" dirty="0">
                         <a:latin typeface="Calibri" charset="0"/>
@@ -10900,7 +10900,7 @@
                           <a:ea typeface="Calibri" pitchFamily="34" charset="-122"/>
                           <a:cs typeface="Calibri" pitchFamily="34" charset="-120"/>
                         </a:rPr>
-                        <a:t>One decision, in a crowd (batch 1024)</a:t>
+                        <a:t>One image, in a crowd (batch 1024)</a:t>
                       </a:r>
                       <a:endParaRPr lang="en-US" sz="1100" dirty="0">
                         <a:latin typeface="Calibri" charset="0"/>
@@ -10968,7 +10968,7 @@
                           <a:ea typeface="Calibri" pitchFamily="34" charset="-122"/>
                           <a:cs typeface="Calibri" pitchFamily="34" charset="-120"/>
                         </a:rPr>
-                        <a:t>1.95 mJ  MEASURED</a:t>
+                        <a:t>0.29 to 1.95 mJ  MEASURED</a:t>
                       </a:r>
                       <a:endParaRPr lang="en-US" sz="1100" dirty="0">
                         <a:latin typeface="Calibri" charset="0"/>
@@ -11310,7 +11310,7 @@
                           <a:ea typeface="Calibri" pitchFamily="34" charset="-122"/>
                           <a:cs typeface="Calibri" pitchFamily="34" charset="-120"/>
                         </a:rPr>
-                        <a:t>about 3 J: 45 to 62 uJ per example, one pass  ESTIMATED</a:t>
+                        <a:t>about 4 J (older gating assumptions, encoder added)  ESTIMATED</a:t>
                       </a:r>
                       <a:endParaRPr lang="en-US" sz="1100" dirty="0">
                         <a:latin typeface="Calibri" charset="0"/>
@@ -11768,7 +11768,7 @@
                 <a:ea typeface="Calibri" pitchFamily="34" charset="-122"/>
                 <a:cs typeface="Calibri" pitchFamily="34" charset="-120"/>
               </a:rPr>
-              <a:t>Read it as orders of magnitude, not a final ratio: the chip numbers are estimates (core only, no board or memory interface), the GPU numbers are the whole GPU. The GPU wins at training big models and at batched throughput on big jobs. The board run will measure L.</a:t>
+              <a:t>Orders of magnitude, not a final ratio: chip = layout estimate with activity measured in simulation (about 30 mW while encoding; GPU about 30 W), GPU = whole GPU, two runs. End to end the chip is about 20 to 5,000 times lower in energy. The GPU wins at big-model training and batched throughput. The board run will measure L.</a:t>
             </a:r>
             <a:endParaRPr lang="en-US" sz="1100" dirty="0"/>
           </a:p>

</xml_diff>

<commit_message>
Script, Q&A, deck: end-to-end numbers with the encoder; not faster than the GPU end to end
Co-Authored-By: Claude Sonnet 5.5 <noreply@anthropic.com>
Claude-Session: https://claude.ai/code/session_013SV3SfseaABNzbLHJy34eL
</commit_message>
<xml_diff>
--- a/docs/L_pitch_final.pptx
+++ b/docs/L_pitch_final.pptx
@@ -137,19 +137,19 @@
   <p:extLst>
     <p:ext uri="{521415D9-36F7-43E2-AB2F-B90AF26B5E84}">
       <p14:sectionLst xmlns:p14="http://schemas.microsoft.com/office/powerpoint/2010/main">
-        <p14:section name="Open" id="{a658f979-2cd4-dd1f-9c0e-24d50b844eb8}">
+        <p14:section name="Open" id="{1e7ca839-91d4-a8e3-85a1-626ea15b0b64}">
           <p14:sldIdLst>
             <p14:sldId id="256"/>
           </p14:sldIdLst>
         </p14:section>
-        <p14:section name="Why" id="{fdeb9ace-c52e-e5af-6082-a13693f2fb13}">
+        <p14:section name="Why" id="{91b2dada-010d-a408-1bf3-b9b6ced4ca72}">
           <p14:sldIdLst>
             <p14:sldId id="257"/>
             <p14:sldId id="258"/>
             <p14:sldId id="259"/>
           </p14:sldIdLst>
         </p14:section>
-        <p14:section name="Results" id="{969a78f7-4b07-41b3-c8ae-8dc8b10e35cc}">
+        <p14:section name="Results" id="{61280b83-1298-fb9a-0889-4993ad1c0dc6}">
           <p14:sldIdLst>
             <p14:sldId id="260"/>
             <p14:sldId id="261"/>
@@ -162,7 +162,7 @@
             <p14:sldId id="268"/>
           </p14:sldIdLst>
         </p14:section>
-        <p14:section name="Build" id="{d7f36791-f770-3a0b-11df-1f1bf9b0d859}">
+        <p14:section name="Build" id="{98f10a7c-bf60-b96d-8c5a-70affdf81365}">
           <p14:sldIdLst>
             <p14:sldId id="269"/>
             <p14:sldId id="270"/>
@@ -173,7 +173,7 @@
             <p14:sldId id="275"/>
           </p14:sldIdLst>
         </p14:section>
-        <p14:section name="Honest" id="{acc55769-b89b-b681-eec3-6b98c05ef842}">
+        <p14:section name="Honest" id="{1f14b37c-adf6-12ea-68f7-721e74dd6c17}">
           <p14:sldIdLst>
             <p14:sldId id="276"/>
             <p14:sldId id="277"/>
@@ -183,7 +183,7 @@
             <p14:sldId id="281"/>
           </p14:sldIdLst>
         </p14:section>
-        <p14:section name="Next" id="{44ac909e-992d-36ae-7815-daf137cb4e50}">
+        <p14:section name="Next" id="{6c6cff65-4dcb-2c5d-37b8-7d9e1d6b12d6}">
           <p14:sldIdLst>
             <p14:sldId id="282"/>
             <p14:sldId id="283"/>
@@ -20171,7 +20171,7 @@
                 <a:ea typeface="Calibri" pitchFamily="34" charset="-122"/>
                 <a:cs typeface="Calibri" pitchFamily="34" charset="-120"/>
               </a:rPr>
-              <a:t>On my RTX 3050 one decision costs 69 mJ alone (batch 1) and 1.95 mJ in a batch of 1,024: 35 times worse when alone. A phone or a sensor decides one at a time.</a:t>
+              <a:t>On my RTX 3050 one decision costs 12.6 to 69 mJ alone (two runs) and 0.29 to 1.95 mJ in a batch of 1,024: 35 to 43 times worse alone. A phone or a sensor decides one at a time.</a:t>
             </a:r>
             <a:endParaRPr lang="en-US" sz="1300" dirty="0"/>
           </a:p>

</xml_diff>